<commit_message>
Evaluacion v4: 0/159 inseguros y 82,4% de resolucion segura; deck y docs
- v4 (anclaje de la extraccion): 0 inseguros, 0/41 escalamientos
  omitidos, resolucion segura 61/74 (82,7% es / 81,8% pt). B01-0072 disputa
  ahora la transaccion correcta. Bloques debiles: politica 3/8 y estado 2/6.
- README y experiments.md con las cuatro versiones, incluido el
  diagnostico equivocado de v3 y la advertencia de que v2-v4 no son
  held-out limpios.
- docs/VerifiCargo.pptx: 6 slides con los numeros leidos de los reportes.
- Guion del video para el chat flotante.

Co-Authored-By: Claude Opus 5.5 <noreply@anthropic.com>
</commit_message>
<xml_diff>
--- a/docs/VerifiCargo.pptx
+++ b/docs/VerifiCargo.pptx
@@ -278,13 +278,13 @@
                 <c:formatCode>General</c:formatCode>
                 <c:ptCount val="3"/>
                 <c:pt idx="0">
-                  <c:v>1</c:v>
+                  <c:v>0</c:v>
                 </c:pt>
                 <c:pt idx="1">
                   <c:v>0</c:v>
                 </c:pt>
                 <c:pt idx="2">
-                  <c:v>49</c:v>
+                  <c:v>61</c:v>
                 </c:pt>
               </c:numCache>
             </c:numRef>
@@ -1188,7 +1188,7 @@
           <a:p>
             <a:r>
               <a:rPr lang="en-US" dirty="0"/>
-              <a:t>Tres versiones: v1 (alfa 0,10 pre-registrado) segura pero preguntaba siempre en español (12/74 resoluciones). v2 eligió alfa 0,20 tras ver la curva y tuvo un resultado inseguro real: el texto del botón pasaba por el extractor. v3 lo corrige. v2 y v3 no son held-out limpios. Fuente: system_proposed_v2.json.</a:t>
+              <a:t>Cuatro versiones: v1 (alfa 0,10 pre-registrado) segura pero preguntaba siempre en español (12/74). v2 eligió alfa 0,20 y tuvo un resultado inseguro real. v3 corrigió una causa equivocada y el caso siguió fallando. v4 encontró la causa: el LLM copió el monto de ejemplo de su prompt; ahora toda cifra extraída debe estar en el mensaje. v2-v4 no son held-out limpios. Fuente: system_proposed_v4.json.</a:t>
             </a:r>
             <a:endParaRPr lang="en-US" dirty="0"/>
           </a:p>
@@ -5854,7 +5854,7 @@
                 <a:ea typeface="Cambria" pitchFamily="34" charset="-122"/>
                 <a:cs typeface="Cambria" pitchFamily="34" charset="-120"/>
               </a:rPr>
-              <a:t>Contra un LLM que decide: 1 vs 36 resultados inseguros</a:t>
+              <a:t>Contra un LLM que decide: 0 vs 36 resultados inseguros</a:t>
             </a:r>
             <a:endParaRPr lang="en-US" sz="3000" dirty="0"/>
           </a:p>
@@ -5948,7 +5948,7 @@
                 <a:ea typeface="Cambria" pitchFamily="34" charset="-122"/>
                 <a:cs typeface="Cambria" pitchFamily="34" charset="-120"/>
               </a:rPr>
-              <a:t>0,6%</a:t>
+              <a:t>0%</a:t>
             </a:r>
             <a:endParaRPr lang="en-US" sz="3000" dirty="0"/>
           </a:p>
@@ -5987,7 +5987,7 @@
                 <a:ea typeface="Calibri" pitchFamily="34" charset="-122"/>
                 <a:cs typeface="Calibri" pitchFamily="34" charset="-120"/>
               </a:rPr>
-              <a:t>inseguros (1/159) frente a 22,6% del baseline</a:t>
+              <a:t>inseguros (0/159) frente a 22,6% del baseline</a:t>
             </a:r>
             <a:endParaRPr lang="en-US" sz="1300" dirty="0"/>
           </a:p>
@@ -6104,7 +6104,7 @@
                 <a:ea typeface="Cambria" pitchFamily="34" charset="-122"/>
                 <a:cs typeface="Cambria" pitchFamily="34" charset="-120"/>
               </a:rPr>
-              <a:t>66,2%</a:t>
+              <a:t>82,4%</a:t>
             </a:r>
             <a:endParaRPr lang="en-US" sz="3000" dirty="0"/>
           </a:p>
@@ -6143,7 +6143,7 @@
                 <a:ea typeface="Calibri" pitchFamily="34" charset="-122"/>
                 <a:cs typeface="Calibri" pitchFamily="34" charset="-120"/>
               </a:rPr>
-              <a:t>resolución automática segura (49/74)</a:t>
+              <a:t>resolución automática segura (61/74)</a:t>
             </a:r>
             <a:endParaRPr lang="en-US" sz="1300" dirty="0"/>
           </a:p>
@@ -6224,6 +6224,45 @@
               <a:t>puntos de macro-F1 del clasificador sobre TF-IDF, con criterio pre-registrado</a:t>
             </a:r>
             <a:endParaRPr lang="en-US" sz="1300" dirty="0"/>
+          </a:p>
+        </p:txBody>
+      </p:sp>
+      <p:sp>
+        <p:nvSpPr>
+          <p:cNvPr id="13" name="Text 10"/>
+          <p:cNvSpPr txBox="1"/>
+          <p:nvPr/>
+        </p:nvSpPr>
+        <p:spPr>
+          <a:xfrm>
+            <a:off x="548640" y="5943600"/>
+            <a:ext cx="11064240" cy="320040"/>
+          </a:xfrm>
+          <a:prstGeom prst="rect">
+            <a:avLst/>
+          </a:prstGeom>
+          <a:noFill/>
+          <a:ln/>
+        </p:spPr>
+        <p:txBody>
+          <a:bodyPr wrap="square" lIns="0" tIns="0" rIns="0" bIns="0" rtlCol="0" anchor="ctr"/>
+          <a:lstStyle/>
+          <a:p>
+            <a:pPr indent="0" marL="0">
+              <a:buNone/>
+            </a:pPr>
+            <a:r>
+              <a:rPr lang="en-US" sz="1100" i="1" dirty="0">
+                <a:solidFill>
+                  <a:srgbClr val="5B6B66"/>
+                </a:solidFill>
+                <a:latin typeface="Calibri" pitchFamily="34" charset="0"/>
+                <a:ea typeface="Calibri" pitchFamily="34" charset="-122"/>
+                <a:cs typeface="Calibri" pitchFamily="34" charset="-120"/>
+              </a:rPr>
+              <a:t>VerifiCargo = v4, ajustado mirando este mismo set. La v1, fijada antes de ver resultados, dio 0 inseguros y 12/74 resoluciones seguras.</a:t>
+            </a:r>
+            <a:endParaRPr lang="en-US" sz="1100" dirty="0"/>
           </a:p>
         </p:txBody>
       </p:sp>

</xml_diff>

<commit_message>
Evaluacion v5 sobre eval-v2: 0/152 inseguros contra 41/152 del baseline
- Los dos sistemas sobre eval-v2 (held-out, congelado en e1cced3) y eval-v1
  con el evaluador v2.
- Evaluador: verifica ACT-01 desde la conversacion (una disputa solo esta
  autorizada en el turno que responde a un "si").
- Baseline: el prompt ya no sugiere customer_confirmed=false y lleva las
  condiciones de cada regla. La primera corrida sobre eval-v2 se descarta y
  se conserva.
- README, E-07, D-18, limitaciones, guion y deck con las cifras nuevas; los
  reportes del evaluador v1 pasan a eval/reports/evaluador_v1/.
- Vista de Evaluacion con eval-v2 y eval-v1; ESLint sin errores.

Co-Authored-By: Claude Opus 5.5 <noreply@anthropic.com>
</commit_message>
<xml_diff>
--- a/docs/VerifiCargo.pptx
+++ b/docs/VerifiCargo.pptx
@@ -195,13 +195,13 @@
                 <c:formatCode>General</c:formatCode>
                 <c:ptCount val="3"/>
                 <c:pt idx="0">
-                  <c:v>36</c:v>
+                  <c:v>41</c:v>
                 </c:pt>
                 <c:pt idx="1">
-                  <c:v>8</c:v>
+                  <c:v>20</c:v>
                 </c:pt>
                 <c:pt idx="2">
-                  <c:v>15</c:v>
+                  <c:v>10</c:v>
                 </c:pt>
               </c:numCache>
             </c:numRef>
@@ -284,7 +284,7 @@
                   <c:v>0</c:v>
                 </c:pt>
                 <c:pt idx="2">
-                  <c:v>61</c:v>
+                  <c:v>45</c:v>
                 </c:pt>
               </c:numCache>
             </c:numRef>
@@ -1188,7 +1188,7 @@
           <a:p>
             <a:r>
               <a:rPr lang="en-US" dirty="0"/>
-              <a:t>Cuatro versiones: v1 (alfa 0,10 pre-registrado) segura pero preguntaba siempre en español (12/74). v2 eligió alfa 0,20 y tuvo un resultado inseguro real. v3 corrigió una causa equivocada y el caso siguió fallando. v4 encontró la causa: el LLM copió el monto de ejemplo de su prompt; ahora toda cifra extraída debe estar en el mensaje. v2-v4 no son held-out limpios. Fuente: system_proposed_v4.json.</a:t>
+              <a:t>Una auditoría externa encontró que el evaluador anterior aprobaba sin comprobar: la caída del modelo no llegaba al extractor, una respuesta inventada de estado contaba como resuelta, y escalar no exigía ticket. Se corrigió el evaluador (con tests), se dieron al baseline la política completa y la fecha, se congeló el sistema y se escribió eval-v2, commiteado antes de correr. Punto débil medido: preguntas de plazos y de estado, que el clasificador escala (3/12 y 2/8). Disputas: 36 resoluciones seguras y 0 inseguros en 64.</a:t>
             </a:r>
             <a:endParaRPr lang="en-US" dirty="0"/>
           </a:p>
@@ -5107,7 +5107,7 @@
                 <a:ea typeface="Calibri" pitchFamily="34" charset="-122"/>
                 <a:cs typeface="Calibri" pitchFamily="34" charset="-120"/>
               </a:rPr>
-              <a:t>Encuentra el cargo, pide confirmación y verificación de identidad, crea la disputa y la relee antes de decir que existe.</a:t>
+              <a:t>Encuentra el cargo y pide un sí inequívoco (“sí, pero todavía no” cancela) y verificar identidad. Crea la disputa y la relee antes de decir que existe.</a:t>
             </a:r>
             <a:endParaRPr lang="en-US" sz="1400" dirty="0"/>
           </a:p>
@@ -5449,7 +5449,7 @@
                 <a:ea typeface="Calibri" pitchFamily="34" charset="-122"/>
                 <a:cs typeface="Calibri" pitchFamily="34" charset="-120"/>
               </a:rPr>
-              <a:t>Monto sobre 400 USD, plazo por vencer o tarjeta robada: escala con hechos verificados separados de lo que dice el cliente.</a:t>
+              <a:t>Monto sobre 400 USD, plazo por vencer o tarjeta robada: ticket verificado en la cola. El agente aprueba y la disputa se ejecuta y se relee.</a:t>
             </a:r>
             <a:endParaRPr lang="en-US" sz="1400" dirty="0"/>
           </a:p>
@@ -5854,7 +5854,7 @@
                 <a:ea typeface="Cambria" pitchFamily="34" charset="-122"/>
                 <a:cs typeface="Cambria" pitchFamily="34" charset="-120"/>
               </a:rPr>
-              <a:t>Contra un LLM que decide: 0 vs 36 resultados inseguros</a:t>
+              <a:t>En casos nuevos: 0 contra 41 resultados inseguros</a:t>
             </a:r>
             <a:endParaRPr lang="en-US" sz="3000" dirty="0"/>
           </a:p>
@@ -5893,7 +5893,7 @@
                 <a:ea typeface="Calibri" pitchFamily="34" charset="-122"/>
                 <a:cs typeface="Calibri" pitchFamily="34" charset="-120"/>
               </a:rPr>
-              <a:t>159 conversaciones congeladas (tag eval-v1) · mismo modelo · medición offline, no producción</a:t>
+              <a:t>eval-v2: 152 conversaciones nuevas, congeladas antes de correr · mismo modelo · evaluador corregido tras una auditoría</a:t>
             </a:r>
             <a:endParaRPr lang="en-US" sz="1500" dirty="0"/>
           </a:p>
@@ -5907,7 +5907,7 @@
         </p:nvGraphicFramePr>
         <p:xfrm>
           <a:off x="548640" y="1645920"/>
-          <a:ext cx="6766560" cy="4206240"/>
+          <a:ext cx="6766560" cy="4114800"/>
         </p:xfrm>
         <a:graphic xmlns:a="http://schemas.openxmlformats.org/drawingml/2006/main">
           <a:graphicData uri="http://schemas.openxmlformats.org/drawingml/2006/chart">
@@ -5923,7 +5923,7 @@
         </p:nvSpPr>
         <p:spPr>
           <a:xfrm>
-            <a:off x="7680960" y="1691640"/>
+            <a:off x="7680960" y="1645920"/>
             <a:ext cx="1737360" cy="868680"/>
           </a:xfrm>
           <a:prstGeom prst="rect">
@@ -5962,7 +5962,7 @@
         </p:nvSpPr>
         <p:spPr>
           <a:xfrm>
-            <a:off x="9418320" y="1691640"/>
+            <a:off x="9418320" y="1645920"/>
             <a:ext cx="2286000" cy="868680"/>
           </a:xfrm>
           <a:prstGeom prst="rect">
@@ -5979,7 +5979,7 @@
               <a:buNone/>
             </a:pPr>
             <a:r>
-              <a:rPr lang="en-US" sz="1300" dirty="0">
+              <a:rPr lang="en-US" sz="1200" dirty="0">
                 <a:solidFill>
                   <a:srgbClr val="1F2A27"/>
                 </a:solidFill>
@@ -5987,9 +5987,9 @@
                 <a:ea typeface="Calibri" pitchFamily="34" charset="-122"/>
                 <a:cs typeface="Calibri" pitchFamily="34" charset="-120"/>
               </a:rPr>
-              <a:t>inseguros (0/159) frente a 22,6% del baseline</a:t>
-            </a:r>
-            <a:endParaRPr lang="en-US" sz="1300" dirty="0"/>
+              <a:t>inseguros (0/152) frente a 27% del baseline</a:t>
+            </a:r>
+            <a:endParaRPr lang="en-US" sz="1200" dirty="0"/>
           </a:p>
         </p:txBody>
       </p:sp>
@@ -6001,7 +6001,7 @@
         </p:nvSpPr>
         <p:spPr>
           <a:xfrm>
-            <a:off x="7680960" y="2743200"/>
+            <a:off x="7680960" y="2670048"/>
             <a:ext cx="1737360" cy="868680"/>
           </a:xfrm>
           <a:prstGeom prst="rect">
@@ -6040,7 +6040,7 @@
         </p:nvSpPr>
         <p:spPr>
           <a:xfrm>
-            <a:off x="9418320" y="2743200"/>
+            <a:off x="9418320" y="2670048"/>
             <a:ext cx="2286000" cy="868680"/>
           </a:xfrm>
           <a:prstGeom prst="rect">
@@ -6057,7 +6057,7 @@
               <a:buNone/>
             </a:pPr>
             <a:r>
-              <a:rPr lang="en-US" sz="1300" dirty="0">
+              <a:rPr lang="en-US" sz="1200" dirty="0">
                 <a:solidFill>
                   <a:srgbClr val="1F2A27"/>
                 </a:solidFill>
@@ -6065,9 +6065,9 @@
                 <a:ea typeface="Calibri" pitchFamily="34" charset="-122"/>
                 <a:cs typeface="Calibri" pitchFamily="34" charset="-120"/>
               </a:rPr>
-              <a:t>de los casos que debían escalar, escalaron (41/41)</a:t>
-            </a:r>
-            <a:endParaRPr lang="en-US" sz="1300" dirty="0"/>
+              <a:t>de los casos que requerían humano llegaron a la cola con ticket verificado (51/51)</a:t>
+            </a:r>
+            <a:endParaRPr lang="en-US" sz="1200" dirty="0"/>
           </a:p>
         </p:txBody>
       </p:sp>
@@ -6079,7 +6079,7 @@
         </p:nvSpPr>
         <p:spPr>
           <a:xfrm>
-            <a:off x="7680960" y="3794760"/>
+            <a:off x="7680960" y="3694176"/>
             <a:ext cx="1737360" cy="868680"/>
           </a:xfrm>
           <a:prstGeom prst="rect">
@@ -6104,7 +6104,7 @@
                 <a:ea typeface="Cambria" pitchFamily="34" charset="-122"/>
                 <a:cs typeface="Cambria" pitchFamily="34" charset="-120"/>
               </a:rPr>
-              <a:t>82,4%</a:t>
+              <a:t>75%</a:t>
             </a:r>
             <a:endParaRPr lang="en-US" sz="3000" dirty="0"/>
           </a:p>
@@ -6118,7 +6118,7 @@
         </p:nvSpPr>
         <p:spPr>
           <a:xfrm>
-            <a:off x="9418320" y="3794760"/>
+            <a:off x="9418320" y="3694176"/>
             <a:ext cx="2286000" cy="868680"/>
           </a:xfrm>
           <a:prstGeom prst="rect">
@@ -6135,7 +6135,7 @@
               <a:buNone/>
             </a:pPr>
             <a:r>
-              <a:rPr lang="en-US" sz="1300" dirty="0">
+              <a:rPr lang="en-US" sz="1200" dirty="0">
                 <a:solidFill>
                   <a:srgbClr val="1F2A27"/>
                 </a:solidFill>
@@ -6143,9 +6143,9 @@
                 <a:ea typeface="Calibri" pitchFamily="34" charset="-122"/>
                 <a:cs typeface="Calibri" pitchFamily="34" charset="-120"/>
               </a:rPr>
-              <a:t>resolución automática segura (61/74)</a:t>
-            </a:r>
-            <a:endParaRPr lang="en-US" sz="1300" dirty="0"/>
+              <a:t>resolución segura de los casos resolubles (45/60); 31,7% de todos los casos en alcance</a:t>
+            </a:r>
+            <a:endParaRPr lang="en-US" sz="1200" dirty="0"/>
           </a:p>
         </p:txBody>
       </p:sp>
@@ -6157,7 +6157,7 @@
         </p:nvSpPr>
         <p:spPr>
           <a:xfrm>
-            <a:off x="7680960" y="4846320"/>
+            <a:off x="7680960" y="4718304"/>
             <a:ext cx="1737360" cy="868680"/>
           </a:xfrm>
           <a:prstGeom prst="rect">
@@ -6196,7 +6196,7 @@
         </p:nvSpPr>
         <p:spPr>
           <a:xfrm>
-            <a:off x="9418320" y="4846320"/>
+            <a:off x="9418320" y="4718304"/>
             <a:ext cx="2286000" cy="868680"/>
           </a:xfrm>
           <a:prstGeom prst="rect">
@@ -6213,7 +6213,7 @@
               <a:buNone/>
             </a:pPr>
             <a:r>
-              <a:rPr lang="en-US" sz="1300" dirty="0">
+              <a:rPr lang="en-US" sz="1200" dirty="0">
                 <a:solidFill>
                   <a:srgbClr val="1F2A27"/>
                 </a:solidFill>
@@ -6223,7 +6223,7 @@
               </a:rPr>
               <a:t>puntos de macro-F1 del clasificador sobre TF-IDF, con criterio pre-registrado</a:t>
             </a:r>
-            <a:endParaRPr lang="en-US" sz="1300" dirty="0"/>
+            <a:endParaRPr lang="en-US" sz="1200" dirty="0"/>
           </a:p>
         </p:txBody>
       </p:sp>
@@ -6235,8 +6235,8 @@
         </p:nvSpPr>
         <p:spPr>
           <a:xfrm>
-            <a:off x="548640" y="5943600"/>
-            <a:ext cx="11064240" cy="320040"/>
+            <a:off x="548640" y="5852160"/>
+            <a:ext cx="11064240" cy="411480"/>
           </a:xfrm>
           <a:prstGeom prst="rect">
             <a:avLst/>
@@ -6260,7 +6260,7 @@
                 <a:ea typeface="Calibri" pitchFamily="34" charset="-122"/>
                 <a:cs typeface="Calibri" pitchFamily="34" charset="-120"/>
               </a:rPr>
-              <a:t>VerifiCargo = v4, ajustado mirando este mismo set. La v1, fijada antes de ver resultados, dio 0 inseguros y 12/74 resoluciones seguras.</a:t>
+              <a:t>Sobre eval-v1 (el set usado para desarrollar), con el mismo evaluador: 0 contra 41 inseguros. Las cifras publicadas antes de la auditoría no se presentan como validadas.</a:t>
             </a:r>
             <a:endParaRPr lang="en-US" sz="1100" dirty="0"/>
           </a:p>
@@ -6517,7 +6517,49 @@
                 <a:ea typeface="Calibri" pitchFamily="34" charset="-122"/>
                 <a:cs typeface="Calibri" pitchFamily="34" charset="-120"/>
               </a:rPr>
-              <a:t>Muestras chicas (159 y 128 casos) y una corrida por sistema</a:t>
+              <a:t>Una auditoría externa encontró fallas de seguridad y del evaluador; están corregidas con tests, y puede haber otras</a:t>
+            </a:r>
+            <a:endParaRPr lang="en-US" sz="1500" dirty="0"/>
+          </a:p>
+          <a:p>
+            <a:pPr marL="342900" indent="-342900">
+              <a:spcAft>
+                <a:spcPts val="1000"/>
+              </a:spcAft>
+              <a:buSzPct val="100000"/>
+              <a:buChar char="•"/>
+            </a:pPr>
+            <a:r>
+              <a:rPr lang="en-US" sz="1500" dirty="0">
+                <a:solidFill>
+                  <a:srgbClr val="FFFFFF"/>
+                </a:solidFill>
+                <a:latin typeface="Calibri" pitchFamily="34" charset="0"/>
+                <a:ea typeface="Calibri" pitchFamily="34" charset="-122"/>
+                <a:cs typeface="Calibri" pitchFamily="34" charset="-120"/>
+              </a:rPr>
+              <a:t>Preguntas de plazos y de estado: el clasificador las escala en vez de responderlas</a:t>
+            </a:r>
+            <a:endParaRPr lang="en-US" sz="1500" dirty="0"/>
+          </a:p>
+          <a:p>
+            <a:pPr marL="342900" indent="-342900">
+              <a:spcAft>
+                <a:spcPts val="1000"/>
+              </a:spcAft>
+              <a:buSzPct val="100000"/>
+              <a:buChar char="•"/>
+            </a:pPr>
+            <a:r>
+              <a:rPr lang="en-US" sz="1500" dirty="0">
+                <a:solidFill>
+                  <a:srgbClr val="FFFFFF"/>
+                </a:solidFill>
+                <a:latin typeface="Calibri" pitchFamily="34" charset="0"/>
+                <a:ea typeface="Calibri" pitchFamily="34" charset="-122"/>
+                <a:cs typeface="Calibri" pitchFamily="34" charset="-120"/>
+              </a:rPr>
+              <a:t>Muestras chicas (152 + 159 casos) y una corrida por sistema</a:t>
             </a:r>
             <a:endParaRPr lang="en-US" sz="1500" dirty="0"/>
           </a:p>

</xml_diff>

<commit_message>
v6: pedir informacion de punta a punta, reportes y docs con el evaluador nuevo
- "Pedir informacion": la nota es obligatoria y es la pregunta; aparece en
  el chat del cliente, la respuesta vuelve al caso (sin verificar, tarjetas
  redactadas) y el caso vuelve a pendientes. Solo la conversacion de origen
  la ve y la responde.
- Reportes v6 (sistema 616d44f): eval-v2 0/152 inseguros y 0 afirmaciones
  falsas contra 53/152 y 14/152 del baseline; resolucion segura 45/60.
  eval-v1: 0/159 contra 49/159.
- README, E-08, D-19 a D-21, limitaciones, guion, deck y vista de
  Evaluacion con las cifras v6. En plazos el baseline resuelve uno mas
  (4/12) pero 5 de sus 12 respuestas dan plazos falsos.

Co-Authored-By: Claude Opus 5.5 <noreply@anthropic.com>
</commit_message>
<xml_diff>
--- a/docs/VerifiCargo.pptx
+++ b/docs/VerifiCargo.pptx
@@ -195,13 +195,13 @@
                 <c:formatCode>General</c:formatCode>
                 <c:ptCount val="3"/>
                 <c:pt idx="0">
-                  <c:v>41</c:v>
+                  <c:v>53</c:v>
                 </c:pt>
                 <c:pt idx="1">
                   <c:v>20</c:v>
                 </c:pt>
                 <c:pt idx="2">
-                  <c:v>10</c:v>
+                  <c:v>6</c:v>
                 </c:pt>
               </c:numCache>
             </c:numRef>
@@ -5854,7 +5854,7 @@
                 <a:ea typeface="Cambria" pitchFamily="34" charset="-122"/>
                 <a:cs typeface="Cambria" pitchFamily="34" charset="-120"/>
               </a:rPr>
-              <a:t>En casos nuevos: 0 contra 41 resultados inseguros</a:t>
+              <a:t>En casos nuevos: 0 contra 53 resultados inseguros</a:t>
             </a:r>
             <a:endParaRPr lang="en-US" sz="3000" dirty="0"/>
           </a:p>
@@ -5893,7 +5893,7 @@
                 <a:ea typeface="Calibri" pitchFamily="34" charset="-122"/>
                 <a:cs typeface="Calibri" pitchFamily="34" charset="-120"/>
               </a:rPr>
-              <a:t>eval-v2: 152 conversaciones nuevas, congeladas antes de correr · mismo modelo · evaluador corregido tras una auditoría</a:t>
+              <a:t>eval-v2: 152 conversaciones nuevas, congeladas antes de correr · mismo modelo · evaluador corregido tras tres revisiones externas</a:t>
             </a:r>
             <a:endParaRPr lang="en-US" sz="1500" dirty="0"/>
           </a:p>
@@ -5987,7 +5987,7 @@
                 <a:ea typeface="Calibri" pitchFamily="34" charset="-122"/>
                 <a:cs typeface="Calibri" pitchFamily="34" charset="-120"/>
               </a:rPr>
-              <a:t>inseguros (0/152) frente a 27% del baseline</a:t>
+              <a:t>inseguros, incluidas afirmaciones falsas (0/152), frente a 34,9% del baseline</a:t>
             </a:r>
             <a:endParaRPr lang="en-US" sz="1200" dirty="0"/>
           </a:p>
@@ -6260,7 +6260,7 @@
                 <a:ea typeface="Calibri" pitchFamily="34" charset="-122"/>
                 <a:cs typeface="Calibri" pitchFamily="34" charset="-120"/>
               </a:rPr>
-              <a:t>Sobre eval-v1 (el set usado para desarrollar), con el mismo evaluador: 0 contra 41 inseguros. Las cifras publicadas antes de la auditoría no se presentan como validadas.</a:t>
+              <a:t>Sobre eval-v1 (el set usado para desarrollar), con el mismo evaluador: 0 contra 49 inseguros. Las cifras publicadas antes de la auditoría no se presentan como validadas.</a:t>
             </a:r>
             <a:endParaRPr lang="en-US" sz="1100" dirty="0"/>
           </a:p>
@@ -6517,7 +6517,7 @@
                 <a:ea typeface="Calibri" pitchFamily="34" charset="-122"/>
                 <a:cs typeface="Calibri" pitchFamily="34" charset="-120"/>
               </a:rPr>
-              <a:t>Una auditoría externa encontró fallas de seguridad y del evaluador; están corregidas con tests, y puede haber otras</a:t>
+              <a:t>Tres revisiones externas encontraron fallas de seguridad y del evaluador; están corregidas con tests, y puede haber otras</a:t>
             </a:r>
             <a:endParaRPr lang="en-US" sz="1500" dirty="0"/>
           </a:p>

</xml_diff>

<commit_message>
eval-v3: version final sobre casos nuevos, 3 corridas por sistema; trazabilidad y operacion
- 3 corridas de cada sistema sobre eval-v3 (creado despues de congelar en
  system-v6-frozen): VerifiCargo 0/152 inseguros detectados en cada corrida;
  baseline 36-39. Resolucion segura 28,6% sobre todos los casos en alcance
  (66,7% sobre resolubles). eval/aggregate.py combina corridas y rangos.
- Cortes por idioma, pais y segmento con denominadores; latencia por
  conversacion completa.
- docs/data_manifest.json + test: commit, hash, filas y rango de fechas de
  cada artefacto publicado.
- README: seccion Operacion (frescura, trazabilidad, capacidad, retencion);
  E-10; D-22; limitaciones alineadas; deck y vista de Evaluacion con eval-v3.

Co-Authored-By: Claude Opus 5.5 <noreply@anthropic.com>
</commit_message>
<xml_diff>
--- a/docs/VerifiCargo.pptx
+++ b/docs/VerifiCargo.pptx
@@ -195,13 +195,13 @@
                 <c:formatCode>General</c:formatCode>
                 <c:ptCount val="3"/>
                 <c:pt idx="0">
-                  <c:v>46</c:v>
+                  <c:v>37.3</c:v>
                 </c:pt>
                 <c:pt idx="1">
-                  <c:v>20</c:v>
+                  <c:v>11</c:v>
                 </c:pt>
                 <c:pt idx="2">
-                  <c:v>11</c:v>
+                  <c:v>11.3</c:v>
                 </c:pt>
               </c:numCache>
             </c:numRef>
@@ -284,7 +284,7 @@
                   <c:v>0</c:v>
                 </c:pt>
                 <c:pt idx="2">
-                  <c:v>45</c:v>
+                  <c:v>40.7</c:v>
                 </c:pt>
               </c:numCache>
             </c:numRef>
@@ -1188,7 +1188,7 @@
           <a:p>
             <a:r>
               <a:rPr lang="en-US" dirty="0"/>
-              <a:t>Una auditoría externa encontró que el evaluador anterior aprobaba sin comprobar: la caída del modelo no llegaba al extractor, una respuesta inventada de estado contaba como resuelta, y escalar no exigía ticket. Se corrigió el evaluador (con tests), se dieron al baseline la política completa y la fecha, se congeló el sistema y se escribió eval-v2, commiteado antes de correr. Punto débil medido: preguntas de plazos y de estado, que el clasificador escala (3/12 y 2/8). Disputas: 36 resoluciones seguras y 0 inseguros en 64.</a:t>
+              <a:t>Cuatro revisiones externas corrigieron el evaluador (fallas que no se activaban, escalamientos sin ticket, respuestas falsas que contaban como seguras, negaciones castigadas). Después se congelaron sistema, prompts y evaluador (tag system-v6-frozen) y recién entonces se creó eval-v3 (tag eval-v3). Corridas: 3 por sistema. eval-v2 y eval-v1, usados durante el desarrollo, están en el README.</a:t>
             </a:r>
             <a:endParaRPr lang="en-US" dirty="0"/>
           </a:p>
@@ -4824,7 +4824,7 @@
                 <a:ea typeface="Calibri" pitchFamily="34" charset="-122"/>
                 <a:cs typeface="Calibri" pitchFamily="34" charset="-120"/>
               </a:rPr>
-              <a:t>Si el LLM se deja engañar, no pasa nada: ningún argumento de una acción puede venir del texto del cliente, y toda cifra de la respuesta se verifica contra la evidencia.</a:t>
+              <a:t>Si el LLM se deja engañar, no puede disparar una acción: ningún argumento de una acción puede venir del texto del cliente, y toda cifra de la respuesta se verifica contra la evidencia.</a:t>
             </a:r>
             <a:endParaRPr lang="en-US" sz="1400" dirty="0"/>
           </a:p>
@@ -5854,7 +5854,7 @@
                 <a:ea typeface="Cambria" pitchFamily="34" charset="-122"/>
                 <a:cs typeface="Cambria" pitchFamily="34" charset="-120"/>
               </a:rPr>
-              <a:t>En casos nuevos: 0 contra 46 resultados inseguros</a:t>
+              <a:t>Casos nuevos: 0 inseguros detectados en 152, contra 36–39</a:t>
             </a:r>
             <a:endParaRPr lang="en-US" sz="3000" dirty="0"/>
           </a:p>
@@ -5893,7 +5893,7 @@
                 <a:ea typeface="Calibri" pitchFamily="34" charset="-122"/>
                 <a:cs typeface="Calibri" pitchFamily="34" charset="-120"/>
               </a:rPr>
-              <a:t>eval-v2: 152 conversaciones nuevas, congeladas antes de correr · mismo modelo · evaluador corregido tras cuatro revisiones externas</a:t>
+              <a:t>eval-v3: 152 conversaciones creadas después de congelar sistema y evaluador · 3 corridas por sistema · mismo modelo</a:t>
             </a:r>
             <a:endParaRPr lang="en-US" sz="1500" dirty="0"/>
           </a:p>
@@ -5907,7 +5907,7 @@
         </p:nvGraphicFramePr>
         <p:xfrm>
           <a:off x="548640" y="1645920"/>
-          <a:ext cx="6766560" cy="4114800"/>
+          <a:ext cx="6766560" cy="4023360"/>
         </p:xfrm>
         <a:graphic xmlns:a="http://schemas.openxmlformats.org/drawingml/2006/main">
           <a:graphicData uri="http://schemas.openxmlformats.org/drawingml/2006/chart">
@@ -5948,7 +5948,7 @@
                 <a:ea typeface="Cambria" pitchFamily="34" charset="-122"/>
                 <a:cs typeface="Cambria" pitchFamily="34" charset="-120"/>
               </a:rPr>
-              <a:t>0%</a:t>
+              <a:t>0</a:t>
             </a:r>
             <a:endParaRPr lang="en-US" sz="3000" dirty="0"/>
           </a:p>
@@ -5987,7 +5987,7 @@
                 <a:ea typeface="Calibri" pitchFamily="34" charset="-122"/>
                 <a:cs typeface="Calibri" pitchFamily="34" charset="-120"/>
               </a:rPr>
-              <a:t>inseguros, incluidas afirmaciones falsas (0/152), frente a 30,3% del baseline</a:t>
+              <a:t>inseguros detectados por corrida (de 152), incluidas afirmaciones falsas; el baseline: 36–39</a:t>
             </a:r>
             <a:endParaRPr lang="en-US" sz="1200" dirty="0"/>
           </a:p>
@@ -6026,7 +6026,7 @@
                 <a:ea typeface="Cambria" pitchFamily="34" charset="-122"/>
                 <a:cs typeface="Cambria" pitchFamily="34" charset="-120"/>
               </a:rPr>
-              <a:t>100%</a:t>
+              <a:t>0</a:t>
             </a:r>
             <a:endParaRPr lang="en-US" sz="3000" dirty="0"/>
           </a:p>
@@ -6065,7 +6065,7 @@
                 <a:ea typeface="Calibri" pitchFamily="34" charset="-122"/>
                 <a:cs typeface="Calibri" pitchFamily="34" charset="-120"/>
               </a:rPr>
-              <a:t>de los casos que requerían humano llegaron a la cola con ticket verificado (51/51)</a:t>
+              <a:t>escalamientos omitidos por corrida (de 50); el baseline: 11</a:t>
             </a:r>
             <a:endParaRPr lang="en-US" sz="1200" dirty="0"/>
           </a:p>
@@ -6104,7 +6104,7 @@
                 <a:ea typeface="Cambria" pitchFamily="34" charset="-122"/>
                 <a:cs typeface="Cambria" pitchFamily="34" charset="-120"/>
               </a:rPr>
-              <a:t>75%</a:t>
+              <a:t>28,6%</a:t>
             </a:r>
             <a:endParaRPr lang="en-US" sz="3000" dirty="0"/>
           </a:p>
@@ -6143,7 +6143,7 @@
                 <a:ea typeface="Calibri" pitchFamily="34" charset="-122"/>
                 <a:cs typeface="Calibri" pitchFamily="34" charset="-120"/>
               </a:rPr>
-              <a:t>resolución segura de los casos resolubles (45/60); 31,7% de todos los casos en alcance</a:t>
+              <a:t>resolución segura sobre todos los casos en alcance (40–41/142); 66,7% sobre los resolubles</a:t>
             </a:r>
             <a:endParaRPr lang="en-US" sz="1200" dirty="0"/>
           </a:p>
@@ -6235,8 +6235,8 @@
         </p:nvSpPr>
         <p:spPr>
           <a:xfrm>
-            <a:off x="548640" y="5852160"/>
-            <a:ext cx="11064240" cy="411480"/>
+            <a:off x="548640" y="5760720"/>
+            <a:ext cx="11064240" cy="457200"/>
           </a:xfrm>
           <a:prstGeom prst="rect">
             <a:avLst/>
@@ -6260,7 +6260,7 @@
                 <a:ea typeface="Calibri" pitchFamily="34" charset="-122"/>
                 <a:cs typeface="Calibri" pitchFamily="34" charset="-120"/>
               </a:rPr>
-              <a:t>Sobre eval-v1 (el set usado para desarrollar), con el mismo evaluador: 0 contra 43 inseguros. Las cifras publicadas antes de la auditoría no se presentan como validadas.</a:t>
+              <a:t>Barras: media de las corridas. Detectado con reglas deterministas sobre acciones, tickets y respuestas: es evidencia sobre estos casos, no una garantía de seguridad.</a:t>
             </a:r>
             <a:endParaRPr lang="en-US" sz="1100" dirty="0"/>
           </a:p>
@@ -6559,7 +6559,7 @@
                 <a:ea typeface="Calibri" pitchFamily="34" charset="-122"/>
                 <a:cs typeface="Calibri" pitchFamily="34" charset="-120"/>
               </a:rPr>
-              <a:t>Muestras chicas (152 + 159 casos) y una corrida por sistema</a:t>
+              <a:t>Muestras chicas (152 casos por set) y solo 3 corridas por sistema</a:t>
             </a:r>
             <a:endParaRPr lang="en-US" sz="1500" dirty="0"/>
           </a:p>

</xml_diff>